<commit_message>
selfie in green shades only
</commit_message>
<xml_diff>
--- a/seflie pixel.pptx
+++ b/seflie pixel.pptx
@@ -105,6 +105,59 @@
     </a:lvl9pPr>
   </p:defaultTextStyle>
 </p:presentation>
+</file>
+
+<file path=ppt/changesInfos/changesInfo1.xml><?xml version="1.0" encoding="utf-8"?>
+<pc:chgInfo xmlns:a="http://schemas.openxmlformats.org/drawingml/2006/main" xmlns:r="http://schemas.openxmlformats.org/officeDocument/2006/relationships" xmlns:ac="http://schemas.microsoft.com/office/drawing/2013/main/command" xmlns:pc="http://schemas.microsoft.com/office/powerpoint/2013/main/command">
+  <pc:docChgLst>
+    <pc:chgData name="Steve Gosselin" userId="570409d37ce2672c" providerId="LiveId" clId="{7EE1BAE4-7B2B-4286-A5BC-36F331E9B30D}"/>
+    <pc:docChg chg="undo custSel modSld">
+      <pc:chgData name="Steve Gosselin" userId="570409d37ce2672c" providerId="LiveId" clId="{7EE1BAE4-7B2B-4286-A5BC-36F331E9B30D}" dt="2026-05-02T13:20:23.190" v="12" actId="1076"/>
+      <pc:docMkLst>
+        <pc:docMk/>
+      </pc:docMkLst>
+      <pc:sldChg chg="addSp delSp modSp mod">
+        <pc:chgData name="Steve Gosselin" userId="570409d37ce2672c" providerId="LiveId" clId="{7EE1BAE4-7B2B-4286-A5BC-36F331E9B30D}" dt="2026-05-02T13:20:23.190" v="12" actId="1076"/>
+        <pc:sldMkLst>
+          <pc:docMk/>
+          <pc:sldMk cId="1342735336" sldId="256"/>
+        </pc:sldMkLst>
+        <pc:picChg chg="mod">
+          <ac:chgData name="Steve Gosselin" userId="570409d37ce2672c" providerId="LiveId" clId="{7EE1BAE4-7B2B-4286-A5BC-36F331E9B30D}" dt="2026-05-02T13:20:17.949" v="10" actId="1076"/>
+          <ac:picMkLst>
+            <pc:docMk/>
+            <pc:sldMk cId="1342735336" sldId="256"/>
+            <ac:picMk id="5" creationId="{7E8E4F70-C07B-3098-5A02-BC5584FFD5FD}"/>
+          </ac:picMkLst>
+        </pc:picChg>
+        <pc:picChg chg="add mod">
+          <ac:chgData name="Steve Gosselin" userId="570409d37ce2672c" providerId="LiveId" clId="{7EE1BAE4-7B2B-4286-A5BC-36F331E9B30D}" dt="2026-05-02T13:20:23.190" v="12" actId="1076"/>
+          <ac:picMkLst>
+            <pc:docMk/>
+            <pc:sldMk cId="1342735336" sldId="256"/>
+            <ac:picMk id="7" creationId="{A18C0F7E-9F43-B03C-B737-6CE149B67585}"/>
+          </ac:picMkLst>
+        </pc:picChg>
+        <pc:picChg chg="add mod">
+          <ac:chgData name="Steve Gosselin" userId="570409d37ce2672c" providerId="LiveId" clId="{7EE1BAE4-7B2B-4286-A5BC-36F331E9B30D}" dt="2026-05-02T13:20:20.596" v="11" actId="1076"/>
+          <ac:picMkLst>
+            <pc:docMk/>
+            <pc:sldMk cId="1342735336" sldId="256"/>
+            <ac:picMk id="9" creationId="{DE070C7F-F1C8-98CF-347C-9DC5FC68D2A0}"/>
+          </ac:picMkLst>
+        </pc:picChg>
+        <pc:picChg chg="add del mod">
+          <ac:chgData name="Steve Gosselin" userId="570409d37ce2672c" providerId="LiveId" clId="{7EE1BAE4-7B2B-4286-A5BC-36F331E9B30D}" dt="2026-05-02T13:20:11.058" v="8" actId="931"/>
+          <ac:picMkLst>
+            <pc:docMk/>
+            <pc:sldMk cId="1342735336" sldId="256"/>
+            <ac:picMk id="11" creationId="{36BA6C4D-1957-CF84-74EF-2865817F643C}"/>
+          </ac:picMkLst>
+        </pc:picChg>
+      </pc:sldChg>
+    </pc:docChg>
+  </pc:docChgLst>
+</pc:chgInfo>
 </file>
 
 <file path=ppt/slideLayouts/slideLayout1.xml><?xml version="1.0" encoding="utf-8"?>
@@ -3362,8 +3415,80 @@
         </p:blipFill>
         <p:spPr>
           <a:xfrm>
-            <a:off x="3352116" y="80963"/>
+            <a:off x="0" y="-80961"/>
             <a:ext cx="5002857" cy="6857999"/>
+          </a:xfrm>
+          <a:prstGeom prst="rect">
+            <a:avLst/>
+          </a:prstGeom>
+        </p:spPr>
+      </p:pic>
+      <p:pic>
+        <p:nvPicPr>
+          <p:cNvPr id="7" name="Graphic 6">
+            <a:extLst>
+              <a:ext uri="{FF2B5EF4-FFF2-40B4-BE49-F238E27FC236}">
+                <a16:creationId xmlns:a16="http://schemas.microsoft.com/office/drawing/2014/main" id="{A18C0F7E-9F43-B03C-B737-6CE149B67585}"/>
+              </a:ext>
+            </a:extLst>
+          </p:cNvPr>
+          <p:cNvPicPr>
+            <a:picLocks noChangeAspect="1"/>
+          </p:cNvPicPr>
+          <p:nvPr/>
+        </p:nvPicPr>
+        <p:blipFill>
+          <a:blip>
+            <a:extLst>
+              <a:ext uri="{96DAC541-7B7A-43D3-8B79-37D633B846F1}">
+                <asvg:svgBlip xmlns:asvg="http://schemas.microsoft.com/office/drawing/2016/SVG/main" r:embed="rId3"/>
+              </a:ext>
+            </a:extLst>
+          </a:blip>
+          <a:stretch>
+            <a:fillRect/>
+          </a:stretch>
+        </p:blipFill>
+        <p:spPr>
+          <a:xfrm>
+            <a:off x="7883669" y="0"/>
+            <a:ext cx="5000625" cy="6858000"/>
+          </a:xfrm>
+          <a:prstGeom prst="rect">
+            <a:avLst/>
+          </a:prstGeom>
+        </p:spPr>
+      </p:pic>
+      <p:pic>
+        <p:nvPicPr>
+          <p:cNvPr id="9" name="Graphic 8">
+            <a:extLst>
+              <a:ext uri="{FF2B5EF4-FFF2-40B4-BE49-F238E27FC236}">
+                <a16:creationId xmlns:a16="http://schemas.microsoft.com/office/drawing/2014/main" id="{DE070C7F-F1C8-98CF-347C-9DC5FC68D2A0}"/>
+              </a:ext>
+            </a:extLst>
+          </p:cNvPr>
+          <p:cNvPicPr>
+            <a:picLocks noChangeAspect="1"/>
+          </p:cNvPicPr>
+          <p:nvPr/>
+        </p:nvPicPr>
+        <p:blipFill>
+          <a:blip>
+            <a:extLst>
+              <a:ext uri="{96DAC541-7B7A-43D3-8B79-37D633B846F1}">
+                <asvg:svgBlip xmlns:asvg="http://schemas.microsoft.com/office/drawing/2016/SVG/main" r:embed="rId4"/>
+              </a:ext>
+            </a:extLst>
+          </a:blip>
+          <a:stretch>
+            <a:fillRect/>
+          </a:stretch>
+        </p:blipFill>
+        <p:spPr>
+          <a:xfrm>
+            <a:off x="3983615" y="0"/>
+            <a:ext cx="5000625" cy="6858000"/>
           </a:xfrm>
           <a:prstGeom prst="rect">
             <a:avLst/>

</xml_diff>